<commit_message>
Deck: update the Path B step-by-step slide with the ID upload, email code details and the gate step
Co-Authored-By: Claude Sonnet 5.5 <noreply@anthropic.com>
</commit_message>
<xml_diff>
--- a/v2/docs/Site-Access-V2-Deck.pptx
+++ b/v2/docs/Site-Access-V2-Deck.pptx
@@ -617,7 +617,7 @@
           <a:p>
             <a:r>
               <a:rPr lang="en-US" dirty="0"/>
-              <a:t>The entrance sign identifies the site only, never a person. Nothing is stored as a person until the email code is entered.</a:t>
+              <a:t>The entrance sign identifies the site only, never a person. Nothing is stored as a person until the email code is entered. At the gate the officer compares the ID with the person by eye.</a:t>
             </a:r>
             <a:endParaRPr lang="en-US" dirty="0"/>
           </a:p>
@@ -3652,7 +3652,7 @@
                 <a:ea typeface="Cambria" pitchFamily="34" charset="-122"/>
                 <a:cs typeface="Cambria" pitchFamily="34" charset="-120"/>
               </a:rPr>
-              <a:t>Path B: unexpected arrival, new in v2</a:t>
+              <a:t>Path B: unexpected arrival, step by step</a:t>
             </a:r>
             <a:endParaRPr lang="en-US" sz="3200" dirty="0"/>
           </a:p>
@@ -3666,12 +3666,12 @@
         </p:nvSpPr>
         <p:spPr>
           <a:xfrm>
-            <a:off x="548640" y="1325880"/>
-            <a:ext cx="3566160" cy="2331720"/>
+            <a:off x="548640" y="1280160"/>
+            <a:ext cx="3566160" cy="2148840"/>
           </a:xfrm>
           <a:prstGeom prst="roundRect">
             <a:avLst>
-              <a:gd name="adj" fmla="val 3922"/>
+              <a:gd name="adj" fmla="val 4255"/>
             </a:avLst>
           </a:prstGeom>
           <a:solidFill>
@@ -3693,7 +3693,7 @@
         </p:nvSpPr>
         <p:spPr>
           <a:xfrm>
-            <a:off x="731520" y="1508760"/>
+            <a:off x="731520" y="1463040"/>
             <a:ext cx="384048" cy="384048"/>
           </a:xfrm>
           <a:prstGeom prst="ellipse">
@@ -3718,7 +3718,7 @@
         </p:nvSpPr>
         <p:spPr>
           <a:xfrm>
-            <a:off x="731520" y="1508760"/>
+            <a:off x="731520" y="1463040"/>
             <a:ext cx="384048" cy="384048"/>
           </a:xfrm>
           <a:prstGeom prst="rect">
@@ -3757,7 +3757,7 @@
         </p:nvSpPr>
         <p:spPr>
           <a:xfrm>
-            <a:off x="1234440" y="1453896"/>
+            <a:off x="1234440" y="1408176"/>
             <a:ext cx="2697480" cy="219456"/>
           </a:xfrm>
           <a:prstGeom prst="rect">
@@ -3796,7 +3796,7 @@
         </p:nvSpPr>
         <p:spPr>
           <a:xfrm>
-            <a:off x="1234440" y="1709928"/>
+            <a:off x="1234440" y="1664208"/>
             <a:ext cx="2697480" cy="365760"/>
           </a:xfrm>
           <a:prstGeom prst="rect">
@@ -3835,8 +3835,8 @@
         </p:nvSpPr>
         <p:spPr>
           <a:xfrm>
-            <a:off x="1234440" y="2112264"/>
-            <a:ext cx="2697480" cy="1463040"/>
+            <a:off x="1234440" y="2066544"/>
+            <a:ext cx="2697480" cy="1280160"/>
           </a:xfrm>
           <a:prstGeom prst="rect">
             <a:avLst/>
@@ -3860,7 +3860,7 @@
                 <a:ea typeface="Calibri" pitchFamily="34" charset="-122"/>
                 <a:cs typeface="Calibri" pitchFamily="34" charset="-120"/>
               </a:rPr>
-              <a:t>A fixed QR at the entrance opens the registration page. No app and no invitation are needed.</a:t>
+              <a:t>A fixed QR at the entrance opens the registration page. No app, no invitation and no account.</a:t>
             </a:r>
             <a:endParaRPr lang="en-US" sz="1400" dirty="0"/>
           </a:p>
@@ -3874,12 +3874,12 @@
         </p:nvSpPr>
         <p:spPr>
           <a:xfrm>
-            <a:off x="4297680" y="1325880"/>
-            <a:ext cx="3566160" cy="2331720"/>
+            <a:off x="4297680" y="1280160"/>
+            <a:ext cx="3566160" cy="2148840"/>
           </a:xfrm>
           <a:prstGeom prst="roundRect">
             <a:avLst>
-              <a:gd name="adj" fmla="val 3922"/>
+              <a:gd name="adj" fmla="val 4255"/>
             </a:avLst>
           </a:prstGeom>
           <a:solidFill>
@@ -3901,7 +3901,7 @@
         </p:nvSpPr>
         <p:spPr>
           <a:xfrm>
-            <a:off x="4480560" y="1508760"/>
+            <a:off x="4480560" y="1463040"/>
             <a:ext cx="384048" cy="384048"/>
           </a:xfrm>
           <a:prstGeom prst="ellipse">
@@ -3926,7 +3926,7 @@
         </p:nvSpPr>
         <p:spPr>
           <a:xfrm>
-            <a:off x="4480560" y="1508760"/>
+            <a:off x="4480560" y="1463040"/>
             <a:ext cx="384048" cy="384048"/>
           </a:xfrm>
           <a:prstGeom prst="rect">
@@ -3965,7 +3965,7 @@
         </p:nvSpPr>
         <p:spPr>
           <a:xfrm>
-            <a:off x="4983480" y="1453896"/>
+            <a:off x="4983480" y="1408176"/>
             <a:ext cx="2697480" cy="219456"/>
           </a:xfrm>
           <a:prstGeom prst="rect">
@@ -4004,7 +4004,7 @@
         </p:nvSpPr>
         <p:spPr>
           <a:xfrm>
-            <a:off x="4983480" y="1709928"/>
+            <a:off x="4983480" y="1664208"/>
             <a:ext cx="2697480" cy="365760"/>
           </a:xfrm>
           <a:prstGeom prst="rect">
@@ -4043,8 +4043,8 @@
         </p:nvSpPr>
         <p:spPr>
           <a:xfrm>
-            <a:off x="4983480" y="2112264"/>
-            <a:ext cx="2697480" cy="1463040"/>
+            <a:off x="4983480" y="2066544"/>
+            <a:ext cx="2697480" cy="1280160"/>
           </a:xfrm>
           <a:prstGeom prst="rect">
             <a:avLst/>
@@ -4068,7 +4068,7 @@
                 <a:ea typeface="Calibri" pitchFamily="34" charset="-122"/>
                 <a:cs typeface="Calibri" pitchFamily="34" charset="-120"/>
               </a:rPr>
-              <a:t>Name, company, email and category, plus a photo or scan of their ID with its expiry date. They preview it before submitting.</a:t>
+              <a:t>Name, company, email and category, plus a photo or scan of their ID and its expiry date, with a preview before submitting.</a:t>
             </a:r>
             <a:endParaRPr lang="en-US" sz="1400" dirty="0"/>
           </a:p>
@@ -4082,12 +4082,12 @@
         </p:nvSpPr>
         <p:spPr>
           <a:xfrm>
-            <a:off x="8046720" y="1325880"/>
-            <a:ext cx="3566160" cy="2331720"/>
+            <a:off x="8046720" y="1280160"/>
+            <a:ext cx="3566160" cy="2148840"/>
           </a:xfrm>
           <a:prstGeom prst="roundRect">
             <a:avLst>
-              <a:gd name="adj" fmla="val 3922"/>
+              <a:gd name="adj" fmla="val 4255"/>
             </a:avLst>
           </a:prstGeom>
           <a:solidFill>
@@ -4109,7 +4109,7 @@
         </p:nvSpPr>
         <p:spPr>
           <a:xfrm>
-            <a:off x="8229600" y="1508760"/>
+            <a:off x="8229600" y="1463040"/>
             <a:ext cx="384048" cy="384048"/>
           </a:xfrm>
           <a:prstGeom prst="ellipse">
@@ -4134,7 +4134,7 @@
         </p:nvSpPr>
         <p:spPr>
           <a:xfrm>
-            <a:off x="8229600" y="1508760"/>
+            <a:off x="8229600" y="1463040"/>
             <a:ext cx="384048" cy="384048"/>
           </a:xfrm>
           <a:prstGeom prst="rect">
@@ -4173,7 +4173,7 @@
         </p:nvSpPr>
         <p:spPr>
           <a:xfrm>
-            <a:off x="8732520" y="1453896"/>
+            <a:off x="8732520" y="1408176"/>
             <a:ext cx="2697480" cy="219456"/>
           </a:xfrm>
           <a:prstGeom prst="rect">
@@ -4212,7 +4212,7 @@
         </p:nvSpPr>
         <p:spPr>
           <a:xfrm>
-            <a:off x="8732520" y="1709928"/>
+            <a:off x="8732520" y="1664208"/>
             <a:ext cx="2697480" cy="365760"/>
           </a:xfrm>
           <a:prstGeom prst="rect">
@@ -4251,8 +4251,8 @@
         </p:nvSpPr>
         <p:spPr>
           <a:xfrm>
-            <a:off x="8732520" y="2112264"/>
-            <a:ext cx="2697480" cy="1463040"/>
+            <a:off x="8732520" y="2066544"/>
+            <a:ext cx="2697480" cy="1280160"/>
           </a:xfrm>
           <a:prstGeom prst="rect">
             <a:avLst/>
@@ -4276,7 +4276,7 @@
                 <a:ea typeface="Calibri" pitchFamily="34" charset="-122"/>
                 <a:cs typeface="Calibri" pitchFamily="34" charset="-120"/>
               </a:rPr>
-              <a:t>The same rules and tick box as Path A, in English or Dutch. Wording, version and time are stored.</a:t>
+              <a:t>The same rules and tick as Path A, in English or Dutch. Wording, version and time are stored.</a:t>
             </a:r>
             <a:endParaRPr lang="en-US" sz="1400" dirty="0"/>
           </a:p>
@@ -4290,12 +4290,12 @@
         </p:nvSpPr>
         <p:spPr>
           <a:xfrm>
-            <a:off x="548640" y="3840480"/>
-            <a:ext cx="3566160" cy="2331720"/>
+            <a:off x="548640" y="3566160"/>
+            <a:ext cx="3566160" cy="2148840"/>
           </a:xfrm>
           <a:prstGeom prst="roundRect">
             <a:avLst>
-              <a:gd name="adj" fmla="val 3922"/>
+              <a:gd name="adj" fmla="val 4255"/>
             </a:avLst>
           </a:prstGeom>
           <a:solidFill>
@@ -4317,7 +4317,7 @@
         </p:nvSpPr>
         <p:spPr>
           <a:xfrm>
-            <a:off x="731520" y="4023360"/>
+            <a:off x="731520" y="3749040"/>
             <a:ext cx="384048" cy="384048"/>
           </a:xfrm>
           <a:prstGeom prst="ellipse">
@@ -4342,7 +4342,7 @@
         </p:nvSpPr>
         <p:spPr>
           <a:xfrm>
-            <a:off x="731520" y="4023360"/>
+            <a:off x="731520" y="3749040"/>
             <a:ext cx="384048" cy="384048"/>
           </a:xfrm>
           <a:prstGeom prst="rect">
@@ -4381,7 +4381,7 @@
         </p:nvSpPr>
         <p:spPr>
           <a:xfrm>
-            <a:off x="1234440" y="3968496"/>
+            <a:off x="1234440" y="3694176"/>
             <a:ext cx="2697480" cy="219456"/>
           </a:xfrm>
           <a:prstGeom prst="rect">
@@ -4420,7 +4420,7 @@
         </p:nvSpPr>
         <p:spPr>
           <a:xfrm>
-            <a:off x="1234440" y="4224528"/>
+            <a:off x="1234440" y="3950208"/>
             <a:ext cx="2697480" cy="365760"/>
           </a:xfrm>
           <a:prstGeom prst="rect">
@@ -4459,8 +4459,8 @@
         </p:nvSpPr>
         <p:spPr>
           <a:xfrm>
-            <a:off x="1234440" y="4626864"/>
-            <a:ext cx="2697480" cy="1463040"/>
+            <a:off x="1234440" y="4352544"/>
+            <a:ext cx="2697480" cy="1280160"/>
           </a:xfrm>
           <a:prstGeom prst="rect">
             <a:avLst/>
@@ -4484,7 +4484,7 @@
                 <a:ea typeface="Calibri" pitchFamily="34" charset="-122"/>
                 <a:cs typeface="Calibri" pitchFamily="34" charset="-120"/>
               </a:rPr>
-              <a:t>A 6-digit code is emailed. Nothing is saved until it is entered.</a:t>
+              <a:t>A 6-digit code is emailed, valid 10 minutes with 5 tries. Nothing is saved until it is entered.</a:t>
             </a:r>
             <a:endParaRPr lang="en-US" sz="1400" dirty="0"/>
           </a:p>
@@ -4498,12 +4498,12 @@
         </p:nvSpPr>
         <p:spPr>
           <a:xfrm>
-            <a:off x="4297680" y="3840480"/>
-            <a:ext cx="3566160" cy="2331720"/>
+            <a:off x="4297680" y="3566160"/>
+            <a:ext cx="3566160" cy="2148840"/>
           </a:xfrm>
           <a:prstGeom prst="roundRect">
             <a:avLst>
-              <a:gd name="adj" fmla="val 3922"/>
+              <a:gd name="adj" fmla="val 4255"/>
             </a:avLst>
           </a:prstGeom>
           <a:solidFill>
@@ -4525,7 +4525,7 @@
         </p:nvSpPr>
         <p:spPr>
           <a:xfrm>
-            <a:off x="4480560" y="4023360"/>
+            <a:off x="4480560" y="3749040"/>
             <a:ext cx="384048" cy="384048"/>
           </a:xfrm>
           <a:prstGeom prst="ellipse">
@@ -4550,7 +4550,7 @@
         </p:nvSpPr>
         <p:spPr>
           <a:xfrm>
-            <a:off x="4480560" y="4023360"/>
+            <a:off x="4480560" y="3749040"/>
             <a:ext cx="384048" cy="384048"/>
           </a:xfrm>
           <a:prstGeom prst="rect">
@@ -4589,7 +4589,7 @@
         </p:nvSpPr>
         <p:spPr>
           <a:xfrm>
-            <a:off x="4983480" y="3968496"/>
+            <a:off x="4983480" y="3694176"/>
             <a:ext cx="2697480" cy="219456"/>
           </a:xfrm>
           <a:prstGeom prst="rect">
@@ -4628,7 +4628,7 @@
         </p:nvSpPr>
         <p:spPr>
           <a:xfrm>
-            <a:off x="4983480" y="4224528"/>
+            <a:off x="4983480" y="3950208"/>
             <a:ext cx="2697480" cy="365760"/>
           </a:xfrm>
           <a:prstGeom prst="rect">
@@ -4667,8 +4667,8 @@
         </p:nvSpPr>
         <p:spPr>
           <a:xfrm>
-            <a:off x="4983480" y="4626864"/>
-            <a:ext cx="2697480" cy="1463040"/>
+            <a:off x="4983480" y="4352544"/>
+            <a:ext cx="2697480" cy="1280160"/>
           </a:xfrm>
           <a:prstGeom prst="rect">
             <a:avLst/>
@@ -4692,7 +4692,7 @@
                 <a:ea typeface="Calibri" pitchFamily="34" charset="-122"/>
                 <a:cs typeface="Calibri" pitchFamily="34" charset="-120"/>
               </a:rPr>
-              <a:t>The phone shows a QR, a reference and its entry and exit time. The site sets when it opens and how long it lasts.</a:t>
+              <a:t>A QR and an 8-character reference with Entry from and Exit by. The site sets when it opens and how long it lasts. A copy is emailed.</a:t>
             </a:r>
             <a:endParaRPr lang="en-US" sz="1400" dirty="0"/>
           </a:p>
@@ -4700,18 +4700,226 @@
       </p:sp>
       <p:sp>
         <p:nvSpPr>
-          <p:cNvPr id="33" name="card Open for Renewi to decide"/>
+          <p:cNvPr id="33" name="card At the gate"/>
           <p:cNvSpPr/>
           <p:nvPr/>
         </p:nvSpPr>
         <p:spPr>
           <a:xfrm>
-            <a:off x="8046720" y="3840480"/>
-            <a:ext cx="3566160" cy="2331720"/>
+            <a:off x="8046720" y="3566160"/>
+            <a:ext cx="3566160" cy="2148840"/>
           </a:xfrm>
           <a:prstGeom prst="roundRect">
             <a:avLst>
-              <a:gd name="adj" fmla="val 3922"/>
+              <a:gd name="adj" fmla="val 4255"/>
+            </a:avLst>
+          </a:prstGeom>
+          <a:solidFill>
+            <a:srgbClr val="FBEFD9"/>
+          </a:solidFill>
+          <a:ln w="12700">
+            <a:solidFill>
+              <a:srgbClr val="B7791F"/>
+            </a:solidFill>
+            <a:prstDash val="solid"/>
+          </a:ln>
+        </p:spPr>
+      </p:sp>
+      <p:sp>
+        <p:nvSpPr>
+          <p:cNvPr id="34" name="num 6"/>
+          <p:cNvSpPr/>
+          <p:nvPr/>
+        </p:nvSpPr>
+        <p:spPr>
+          <a:xfrm>
+            <a:off x="8229600" y="3749040"/>
+            <a:ext cx="384048" cy="384048"/>
+          </a:xfrm>
+          <a:prstGeom prst="ellipse">
+            <a:avLst/>
+          </a:prstGeom>
+          <a:solidFill>
+            <a:srgbClr val="B7791F"/>
+          </a:solidFill>
+          <a:ln w="12700">
+            <a:solidFill>
+              <a:srgbClr val="B7791F"/>
+            </a:solidFill>
+            <a:prstDash val="solid"/>
+          </a:ln>
+        </p:spPr>
+      </p:sp>
+      <p:sp>
+        <p:nvSpPr>
+          <p:cNvPr id="35" name="Text 33"/>
+          <p:cNvSpPr txBox="1"/>
+          <p:nvPr/>
+        </p:nvSpPr>
+        <p:spPr>
+          <a:xfrm>
+            <a:off x="8229600" y="3749040"/>
+            <a:ext cx="384048" cy="384048"/>
+          </a:xfrm>
+          <a:prstGeom prst="rect">
+            <a:avLst/>
+          </a:prstGeom>
+          <a:noFill/>
+          <a:ln/>
+        </p:spPr>
+        <p:txBody>
+          <a:bodyPr wrap="square" lIns="0" tIns="0" rIns="0" bIns="0" rtlCol="0" anchor="ctr"/>
+          <a:lstStyle/>
+          <a:p>
+            <a:pPr algn="ctr" indent="0" marL="0">
+              <a:buNone/>
+            </a:pPr>
+            <a:r>
+              <a:rPr lang="en-US" sz="1400" b="1" dirty="0">
+                <a:solidFill>
+                  <a:srgbClr val="FFFFFF"/>
+                </a:solidFill>
+                <a:latin typeface="Calibri" pitchFamily="34" charset="0"/>
+                <a:ea typeface="Calibri" pitchFamily="34" charset="-122"/>
+                <a:cs typeface="Calibri" pitchFamily="34" charset="-120"/>
+              </a:rPr>
+              <a:t>6</a:t>
+            </a:r>
+            <a:endParaRPr lang="en-US" sz="1400" dirty="0"/>
+          </a:p>
+        </p:txBody>
+      </p:sp>
+      <p:sp>
+        <p:nvSpPr>
+          <p:cNvPr id="36" name="Text 34"/>
+          <p:cNvSpPr txBox="1"/>
+          <p:nvPr/>
+        </p:nvSpPr>
+        <p:spPr>
+          <a:xfrm>
+            <a:off x="8732520" y="3694176"/>
+            <a:ext cx="2697480" cy="219456"/>
+          </a:xfrm>
+          <a:prstGeom prst="rect">
+            <a:avLst/>
+          </a:prstGeom>
+          <a:noFill/>
+          <a:ln/>
+        </p:spPr>
+        <p:txBody>
+          <a:bodyPr wrap="square" lIns="0" tIns="0" rIns="0" bIns="0" rtlCol="0" anchor="ctr"/>
+          <a:lstStyle/>
+          <a:p>
+            <a:pPr indent="0" marL="0">
+              <a:buNone/>
+            </a:pPr>
+            <a:r>
+              <a:rPr lang="en-US" sz="1100" b="1" spc="200" kern="0" dirty="0">
+                <a:solidFill>
+                  <a:srgbClr val="B7791F"/>
+                </a:solidFill>
+                <a:latin typeface="Calibri" pitchFamily="34" charset="0"/>
+                <a:ea typeface="Calibri" pitchFamily="34" charset="-122"/>
+                <a:cs typeface="Calibri" pitchFamily="34" charset="-120"/>
+              </a:rPr>
+              <a:t>GATE OFFICER</a:t>
+            </a:r>
+            <a:endParaRPr lang="en-US" sz="1100" dirty="0"/>
+          </a:p>
+        </p:txBody>
+      </p:sp>
+      <p:sp>
+        <p:nvSpPr>
+          <p:cNvPr id="37" name="Text 35"/>
+          <p:cNvSpPr txBox="1"/>
+          <p:nvPr/>
+        </p:nvSpPr>
+        <p:spPr>
+          <a:xfrm>
+            <a:off x="8732520" y="3950208"/>
+            <a:ext cx="2697480" cy="365760"/>
+          </a:xfrm>
+          <a:prstGeom prst="rect">
+            <a:avLst/>
+          </a:prstGeom>
+          <a:noFill/>
+          <a:ln/>
+        </p:spPr>
+        <p:txBody>
+          <a:bodyPr wrap="square" lIns="0" tIns="0" rIns="0" bIns="0" rtlCol="0" anchor="ctr"/>
+          <a:lstStyle/>
+          <a:p>
+            <a:pPr indent="0" marL="0">
+              <a:buNone/>
+            </a:pPr>
+            <a:r>
+              <a:rPr lang="en-US" sz="1600" b="1" dirty="0">
+                <a:solidFill>
+                  <a:srgbClr val="573906"/>
+                </a:solidFill>
+                <a:latin typeface="Calibri" pitchFamily="34" charset="0"/>
+                <a:ea typeface="Calibri" pitchFamily="34" charset="-122"/>
+                <a:cs typeface="Calibri" pitchFamily="34" charset="-120"/>
+              </a:rPr>
+              <a:t>At the gate</a:t>
+            </a:r>
+            <a:endParaRPr lang="en-US" sz="1600" dirty="0"/>
+          </a:p>
+        </p:txBody>
+      </p:sp>
+      <p:sp>
+        <p:nvSpPr>
+          <p:cNvPr id="38" name="Text 36"/>
+          <p:cNvSpPr txBox="1"/>
+          <p:nvPr/>
+        </p:nvSpPr>
+        <p:spPr>
+          <a:xfrm>
+            <a:off x="8732520" y="4352544"/>
+            <a:ext cx="2697480" cy="1280160"/>
+          </a:xfrm>
+          <a:prstGeom prst="rect">
+            <a:avLst/>
+          </a:prstGeom>
+          <a:noFill/>
+          <a:ln/>
+        </p:spPr>
+        <p:txBody>
+          <a:bodyPr wrap="square" lIns="0" tIns="0" rIns="0" bIns="0" rtlCol="0" anchor="t"/>
+          <a:lstStyle/>
+          <a:p>
+            <a:pPr indent="0" marL="0">
+              <a:buNone/>
+            </a:pPr>
+            <a:r>
+              <a:rPr lang="en-US" sz="1400" dirty="0">
+                <a:solidFill>
+                  <a:srgbClr val="573906"/>
+                </a:solidFill>
+                <a:latin typeface="Calibri" pitchFamily="34" charset="0"/>
+                <a:ea typeface="Calibri" pitchFamily="34" charset="-122"/>
+                <a:cs typeface="Calibri" pitchFamily="34" charset="-120"/>
+              </a:rPr>
+              <a:t>The officer checks the reference or QR, opens the ID to compare, then lets them in or refuses. Exit is recorded when they leave.</a:t>
+            </a:r>
+            <a:endParaRPr lang="en-US" sz="1400" dirty="0"/>
+          </a:p>
+        </p:txBody>
+      </p:sp>
+      <p:sp>
+        <p:nvSpPr>
+          <p:cNvPr id="39" name="Shape 37"/>
+          <p:cNvSpPr/>
+          <p:nvPr/>
+        </p:nvSpPr>
+        <p:spPr>
+          <a:xfrm>
+            <a:off x="548640" y="5897880"/>
+            <a:ext cx="11091672" cy="457200"/>
+          </a:xfrm>
+          <a:prstGeom prst="roundRect">
+            <a:avLst>
+              <a:gd name="adj" fmla="val 16000"/>
             </a:avLst>
           </a:prstGeom>
           <a:solidFill>
@@ -4727,30 +4935,30 @@
       </p:sp>
       <p:sp>
         <p:nvSpPr>
-          <p:cNvPr id="34" name="Text 32"/>
-          <p:cNvSpPr txBox="1"/>
-          <p:nvPr/>
-        </p:nvSpPr>
-        <p:spPr>
-          <a:xfrm>
-            <a:off x="8275320" y="3968496"/>
-            <a:ext cx="3154680" cy="219456"/>
-          </a:xfrm>
-          <a:prstGeom prst="rect">
-            <a:avLst/>
-          </a:prstGeom>
-          <a:noFill/>
-          <a:ln/>
-        </p:spPr>
-        <p:txBody>
-          <a:bodyPr wrap="square" lIns="0" tIns="0" rIns="0" bIns="0" rtlCol="0" anchor="ctr"/>
-          <a:lstStyle/>
-          <a:p>
-            <a:pPr indent="0" marL="0">
-              <a:buNone/>
-            </a:pPr>
-            <a:r>
-              <a:rPr lang="en-US" sz="1100" b="1" spc="200" kern="0" dirty="0">
+          <p:cNvPr id="40" name="Text 38"/>
+          <p:cNvSpPr txBox="1"/>
+          <p:nvPr/>
+        </p:nvSpPr>
+        <p:spPr>
+          <a:xfrm>
+            <a:off x="731520" y="5897880"/>
+            <a:ext cx="10789920" cy="457200"/>
+          </a:xfrm>
+          <a:prstGeom prst="rect">
+            <a:avLst/>
+          </a:prstGeom>
+          <a:noFill/>
+          <a:ln/>
+        </p:spPr>
+        <p:txBody>
+          <a:bodyPr wrap="square" lIns="0" tIns="0" rIns="0" bIns="0" rtlCol="0" anchor="ctr"/>
+          <a:lstStyle/>
+          <a:p>
+            <a:pPr indent="0" marL="0">
+              <a:buNone/>
+            </a:pPr>
+            <a:r>
+              <a:rPr lang="en-US" sz="1100" b="1" dirty="0">
                 <a:solidFill>
                   <a:srgbClr val="D85A30"/>
                 </a:solidFill>
@@ -4758,87 +4966,23 @@
                 <a:ea typeface="Calibri" pitchFamily="34" charset="-122"/>
                 <a:cs typeface="Calibri" pitchFamily="34" charset="-120"/>
               </a:rPr>
-              <a:t>OPEN QUESTION</a:t>
+              <a:t>OPEN FOR RENEWI  </a:t>
+            </a:r>
+            <a:pPr indent="0" marL="0">
+              <a:buNone/>
+            </a:pPr>
+            <a:r>
+              <a:rPr lang="en-US" sz="1400" dirty="0">
+                <a:solidFill>
+                  <a:srgbClr val="8A2E10"/>
+                </a:solidFill>
+                <a:latin typeface="Calibri" pitchFamily="34" charset="0"/>
+                <a:ea typeface="Calibri" pitchFamily="34" charset="-122"/>
+                <a:cs typeface="Calibri" pitchFamily="34" charset="-120"/>
+              </a:rPr>
+              <a:t>Who may use Path B, and how do we know they are expected?</a:t>
             </a:r>
             <a:endParaRPr lang="en-US" sz="1100" dirty="0"/>
-          </a:p>
-        </p:txBody>
-      </p:sp>
-      <p:sp>
-        <p:nvSpPr>
-          <p:cNvPr id="35" name="Text 33"/>
-          <p:cNvSpPr txBox="1"/>
-          <p:nvPr/>
-        </p:nvSpPr>
-        <p:spPr>
-          <a:xfrm>
-            <a:off x="8275320" y="4224528"/>
-            <a:ext cx="3154680" cy="365760"/>
-          </a:xfrm>
-          <a:prstGeom prst="rect">
-            <a:avLst/>
-          </a:prstGeom>
-          <a:noFill/>
-          <a:ln/>
-        </p:spPr>
-        <p:txBody>
-          <a:bodyPr wrap="square" lIns="0" tIns="0" rIns="0" bIns="0" rtlCol="0" anchor="ctr"/>
-          <a:lstStyle/>
-          <a:p>
-            <a:pPr indent="0" marL="0">
-              <a:buNone/>
-            </a:pPr>
-            <a:r>
-              <a:rPr lang="en-US" sz="1600" b="1" dirty="0">
-                <a:solidFill>
-                  <a:srgbClr val="8A2E10"/>
-                </a:solidFill>
-                <a:latin typeface="Calibri" pitchFamily="34" charset="0"/>
-                <a:ea typeface="Calibri" pitchFamily="34" charset="-122"/>
-                <a:cs typeface="Calibri" pitchFamily="34" charset="-120"/>
-              </a:rPr>
-              <a:t>Open for Renewi to decide</a:t>
-            </a:r>
-            <a:endParaRPr lang="en-US" sz="1600" dirty="0"/>
-          </a:p>
-        </p:txBody>
-      </p:sp>
-      <p:sp>
-        <p:nvSpPr>
-          <p:cNvPr id="36" name="Text 34"/>
-          <p:cNvSpPr txBox="1"/>
-          <p:nvPr/>
-        </p:nvSpPr>
-        <p:spPr>
-          <a:xfrm>
-            <a:off x="8275320" y="4626864"/>
-            <a:ext cx="3154680" cy="1463040"/>
-          </a:xfrm>
-          <a:prstGeom prst="rect">
-            <a:avLst/>
-          </a:prstGeom>
-          <a:noFill/>
-          <a:ln/>
-        </p:spPr>
-        <p:txBody>
-          <a:bodyPr wrap="square" lIns="0" tIns="0" rIns="0" bIns="0" rtlCol="0" anchor="t"/>
-          <a:lstStyle/>
-          <a:p>
-            <a:pPr indent="0" marL="0">
-              <a:buNone/>
-            </a:pPr>
-            <a:r>
-              <a:rPr lang="en-US" sz="1400" dirty="0">
-                <a:solidFill>
-                  <a:srgbClr val="8A2E10"/>
-                </a:solidFill>
-                <a:latin typeface="Calibri" pitchFamily="34" charset="0"/>
-                <a:ea typeface="Calibri" pitchFamily="34" charset="-122"/>
-                <a:cs typeface="Calibri" pitchFamily="34" charset="-120"/>
-              </a:rPr>
-              <a:t>Who may use Path B, and how do we know they are expected? Today the officer's own judgment is the only check.</a:t>
-            </a:r>
-            <a:endParaRPr lang="en-US" sz="1400" dirty="0"/>
           </a:p>
         </p:txBody>
       </p:sp>

</xml_diff>